<commit_message>
Phase 1: replace circular benchmark with held-out evaluation and honest error analysis
</commit_message>
<xml_diff>
--- a/deliverables/exathon-india-2026-pitch.pptx
+++ b/deliverables/exathon-india-2026-pitch.pptx
@@ -2,17 +2,17 @@
 <file path=ppt/presentation.xml><?xml version="1.0" encoding="utf-8"?>
 <p:presentation xmlns:p="http://schemas.openxmlformats.org/presentationml/2006/main">
   <p:sldMasterIdLst>
-    <p:sldMasterId xmlns:r="http://schemas.openxmlformats.org/officeDocument/2006/relationships" id="2147483648" r:id="R11971df894d445c8"/>
+    <p:sldMasterId xmlns:r="http://schemas.openxmlformats.org/officeDocument/2006/relationships" id="2147483648" r:id="Rf12acca58e084478"/>
   </p:sldMasterIdLst>
   <p:notesMasterIdLst>
-    <p:notesMasterId xmlns:r="http://schemas.openxmlformats.org/officeDocument/2006/relationships" r:id="Rf69a5fcfd2644346"/>
+    <p:notesMasterId xmlns:r="http://schemas.openxmlformats.org/officeDocument/2006/relationships" r:id="R654489c704354f4f"/>
   </p:notesMasterIdLst>
   <p:sldIdLst>
-    <p:sldId xmlns:r="http://schemas.openxmlformats.org/officeDocument/2006/relationships" id="256" r:id="Refafeefd17844a56"/>
-    <p:sldId xmlns:r="http://schemas.openxmlformats.org/officeDocument/2006/relationships" id="257" r:id="Reee0d2fa003c47c6"/>
-    <p:sldId xmlns:r="http://schemas.openxmlformats.org/officeDocument/2006/relationships" id="258" r:id="Rc71eaa69154f4828"/>
-    <p:sldId xmlns:r="http://schemas.openxmlformats.org/officeDocument/2006/relationships" id="259" r:id="Rdb9d3a239b2f4f03"/>
-    <p:sldId xmlns:r="http://schemas.openxmlformats.org/officeDocument/2006/relationships" id="260" r:id="R9227f92faeb74691"/>
+    <p:sldId xmlns:r="http://schemas.openxmlformats.org/officeDocument/2006/relationships" id="256" r:id="Rb0298c7556494f0d"/>
+    <p:sldId xmlns:r="http://schemas.openxmlformats.org/officeDocument/2006/relationships" id="257" r:id="Rbf8bad221f204676"/>
+    <p:sldId xmlns:r="http://schemas.openxmlformats.org/officeDocument/2006/relationships" id="258" r:id="Ra63aaf4b420b4ae3"/>
+    <p:sldId xmlns:r="http://schemas.openxmlformats.org/officeDocument/2006/relationships" id="259" r:id="R90fddb03dc174fb9"/>
+    <p:sldId xmlns:r="http://schemas.openxmlformats.org/officeDocument/2006/relationships" id="260" r:id="Recfc93ef48724649"/>
   </p:sldIdLst>
   <p:sldSz cx="12192000" cy="6858000"/>
   <p:notesSz cx="6858000" cy="9144000"/>
@@ -661,7 +661,7 @@
           <a:lstStyle xmlns:a="http://schemas.openxmlformats.org/drawingml/2006/main"/>
           <a:p xmlns:a="http://schemas.openxmlformats.org/drawingml/2006/main">
             <a:r>
-              <a:t>Measured using the seeded large dataset on Exasol Personal local VM configured with 8 GB. Factory-level scoring counts a cheat or decoy once if any of its three months is prioritized. These synthetic results do not establish expected performance on real investigations.</a:t>
+              <a:t>Source: results.json. Factory-month intervals and subgroup results: reports/evaluation.md. This operating point is not suitable for automated taxpayer action. Monthly queues approximate weekly workload. Any-month annual aggregation inflates false positives.</a:t>
             </a:r>
           </a:p>
         </p:txBody>
@@ -731,17 +731,7 @@
           <a:lstStyle xmlns:a="http://schemas.openxmlformats.org/drawingml/2006/main"/>
           <a:p xmlns:a="http://schemas.openxmlformats.org/drawingml/2006/main">
             <a:r>
-              <a:t>Use this slide as a brief pattern comparison, not a legal equivalence claim.</a:t>
-            </a:r>
-          </a:p>
-          <a:p xmlns:a="http://schemas.openxmlformats.org/drawingml/2006/main">
-            <a:r>
-              <a:t>EPPO, “Germany: EPPO orders searches and arrest in probe into €18 million VAT fraud”, 13 May 2026: https://www.eppo.europa.eu/media/news/germany-eppo-orders-search-and-arrest-probe-eu18-million-vat-fraud-2026-05-13_en</a:t>
-            </a:r>
-          </a:p>
-          <a:p xmlns:a="http://schemas.openxmlformats.org/drawingml/2006/main">
-            <a:r>
-              <a:t>European Commission, “VAT carousel fraud”: https://taxation-customs.ec.europa.eu/taxation/vat/fight-against-vat-fraud/vat-carousel-fraud_en</a:t>
+              <a:t>A proposed future application, not a measured German deployment. No German statistics claimed.</a:t>
             </a:r>
           </a:p>
         </p:txBody>
@@ -3184,12 +3174,12 @@
   </p:cSld>
   <p:clrMap bg1="lt1" tx1="dk1" bg2="lt2" tx2="dk2" accent1="accent1" accent2="accent2" accent3="accent3" accent4="accent4" accent5="accent5" accent6="accent6" hlink="hlink" folHlink="folHlink"/>
   <p:sldLayoutIdLst>
-    <p:sldLayoutId xmlns:r="http://schemas.openxmlformats.org/officeDocument/2006/relationships" id="2147483649" r:id="Rd6370313429543da"/>
-    <p:sldLayoutId xmlns:r="http://schemas.openxmlformats.org/officeDocument/2006/relationships" id="2147483650" r:id="R337fb4ca6ee44e13"/>
-    <p:sldLayoutId xmlns:r="http://schemas.openxmlformats.org/officeDocument/2006/relationships" id="2147483651" r:id="Re177ed01ce9347a9"/>
-    <p:sldLayoutId xmlns:r="http://schemas.openxmlformats.org/officeDocument/2006/relationships" id="2147483652" r:id="R4871d7be281447f0"/>
-    <p:sldLayoutId xmlns:r="http://schemas.openxmlformats.org/officeDocument/2006/relationships" id="2147483653" r:id="Red3a4dcc1a184c5f"/>
-    <p:sldLayoutId xmlns:r="http://schemas.openxmlformats.org/officeDocument/2006/relationships" id="2147483654" r:id="R777631df3d024fa4"/>
+    <p:sldLayoutId xmlns:r="http://schemas.openxmlformats.org/officeDocument/2006/relationships" id="2147483649" r:id="Ra1655fe966be4c2b"/>
+    <p:sldLayoutId xmlns:r="http://schemas.openxmlformats.org/officeDocument/2006/relationships" id="2147483650" r:id="R14affdafc3db41e3"/>
+    <p:sldLayoutId xmlns:r="http://schemas.openxmlformats.org/officeDocument/2006/relationships" id="2147483651" r:id="Rb5dce4c675a640a2"/>
+    <p:sldLayoutId xmlns:r="http://schemas.openxmlformats.org/officeDocument/2006/relationships" id="2147483652" r:id="R2799cde0b3a54010"/>
+    <p:sldLayoutId xmlns:r="http://schemas.openxmlformats.org/officeDocument/2006/relationships" id="2147483653" r:id="R5e88bf51c0e1460a"/>
+    <p:sldLayoutId xmlns:r="http://schemas.openxmlformats.org/officeDocument/2006/relationships" id="2147483654" r:id="Rd8435d8ef51c422c"/>
   </p:sldLayoutIdLst>
   <p:txStyles>
     <p:titleStyle>
@@ -12531,7 +12521,7 @@
                 <a:ea typeface="Arial"/>
                 <a:cs typeface="Arial"/>
               </a:rPr>
-              <a:t>PRIORITISE ONLY WITH 2+ CHECK FAMILIES</a:t>
+              <a:t>PRIORITISE WITH 2+ DISTINCT SOURCE FAMILIES</a:t>
             </a:r>
           </a:p>
         </p:txBody>
@@ -12703,7 +12693,7 @@
                 <a:ea typeface="Arial"/>
                 <a:cs typeface="Arial"/>
               </a:rPr>
-              <a:t>One signal → human review   ·   no signal → clear</a:t>
+              <a:t>Single-source cases stay outside the priority queue</a:t>
             </a:r>
           </a:p>
         </p:txBody>
@@ -13484,7 +13474,7 @@
                 <a:ea typeface="Arial"/>
                 <a:cs typeface="Arial"/>
               </a:rPr>
-              <a:t>2.51 million rows, reconciled in Exasol Personal.</a:t>
+              <a:t>Held-out evaluation exposes the false-positive cost</a:t>
             </a:r>
           </a:p>
         </p:txBody>
@@ -14064,7 +14054,7 @@
                 <a:ea typeface="Arial"/>
                 <a:cs typeface="Arial"/>
               </a:rPr>
-              <a:t>100%</a:t>
+              <a:t>84.42%</a:t>
             </a:r>
           </a:p>
         </p:txBody>
@@ -14236,7 +14226,7 @@
                 <a:ea typeface="Arial"/>
                 <a:cs typeface="Arial"/>
               </a:rPr>
-              <a:t>cheats caught</a:t>
+              <a:t>monthly cheat recall</a:t>
             </a:r>
           </a:p>
         </p:txBody>
@@ -14408,7 +14398,7 @@
                 <a:ea typeface="Arial"/>
                 <a:cs typeface="Arial"/>
               </a:rPr>
-              <a:t>24,000 / 24,000 factories</a:t>
+              <a:t>3409 / 4038 active cheat months</a:t>
             </a:r>
           </a:p>
         </p:txBody>
@@ -14613,7 +14603,7 @@
                 <a:ea typeface="Arial"/>
                 <a:cs typeface="Arial"/>
               </a:rPr>
-              <a:t>0%</a:t>
+              <a:t>16.76%</a:t>
             </a:r>
           </a:p>
         </p:txBody>
@@ -14785,7 +14775,7 @@
                 <a:ea typeface="Arial"/>
                 <a:cs typeface="Arial"/>
               </a:rPr>
-              <a:t>decoys prioritised</a:t>
+              <a:t>monthly false-positive rate</a:t>
             </a:r>
           </a:p>
         </p:txBody>
@@ -14957,7 +14947,7 @@
                 <a:ea typeface="Arial"/>
                 <a:cs typeface="Arial"/>
               </a:rPr>
-              <a:t>0 / 24,000 honest decoys</a:t>
+              <a:t>4151 / 24762 negative months</a:t>
             </a:r>
           </a:p>
         </p:txBody>
@@ -15162,7 +15152,7 @@
                 <a:ea typeface="Arial"/>
                 <a:cs typeface="Arial"/>
               </a:rPr>
-              <a:t>1.407 s</a:t>
+              <a:t>629</a:t>
             </a:r>
           </a:p>
         </p:txBody>
@@ -15334,7 +15324,7 @@
                 <a:ea typeface="Arial"/>
                 <a:cs typeface="Arial"/>
               </a:rPr>
-              <a:t>priority query</a:t>
+              <a:t>active cheat months missed</a:t>
             </a:r>
           </a:p>
         </p:txBody>
@@ -15506,7 +15496,7 @@
                 <a:ea typeface="Arial"/>
                 <a:cs typeface="Arial"/>
               </a:rPr>
-              <a:t>72,000 factory-month cases</a:t>
+              <a:t>5 cheat factories never caught</a:t>
             </a:r>
           </a:p>
         </p:txBody>
@@ -15678,7 +15668,7 @@
                 <a:ea typeface="Arial"/>
                 <a:cs typeface="Arial"/>
               </a:rPr>
-              <a:t>FULL-SCALE DATASET</a:t>
+              <a:t>HELD-OUT SEED B</a:t>
             </a:r>
           </a:p>
         </p:txBody>
@@ -15850,7 +15840,7 @@
                 <a:ea typeface="Arial"/>
                 <a:cs typeface="Arial"/>
               </a:rPr>
-              <a:t>120,000 factories</a:t>
+              <a:t>2,400 factories</a:t>
             </a:r>
           </a:p>
         </p:txBody>
@@ -16022,7 +16012,7 @@
                 <a:ea typeface="Arial"/>
                 <a:cs typeface="Arial"/>
               </a:rPr>
-              <a:t>360,000 factory-months</a:t>
+              <a:t>28,800 factory-months</a:t>
             </a:r>
           </a:p>
         </p:txBody>
@@ -16194,7 +16184,7 @@
                 <a:ea typeface="Arial"/>
                 <a:cs typeface="Arial"/>
               </a:rPr>
-              <a:t>2,510,000 evidence rows</a:t>
+              <a:t>228,854 raw evidence rows</a:t>
             </a:r>
           </a:p>
         </p:txBody>
@@ -16399,7 +16389,7 @@
                 <a:ea typeface="Arial"/>
                 <a:cs typeface="Arial"/>
               </a:rPr>
-              <a:t>SQL VIEW TIMING</a:t>
+              <a:t>ANNUAL SCORES AND QUEUE PRECISION</a:t>
             </a:r>
           </a:p>
         </p:txBody>
@@ -16571,7 +16561,7 @@
                 <a:ea typeface="Arial"/>
                 <a:cs typeface="Arial"/>
               </a:rPr>
-              <a:t>Material / output</a:t>
+              <a:t>Factory recall</a:t>
             </a:r>
           </a:p>
         </p:txBody>
@@ -16743,7 +16733,7 @@
                 <a:ea typeface="Arial"/>
                 <a:cs typeface="Arial"/>
               </a:rPr>
-              <a:t>0.012 s</a:t>
+              <a:t>99.31%</a:t>
             </a:r>
           </a:p>
         </p:txBody>
@@ -16915,7 +16905,7 @@
                 <a:ea typeface="Arial"/>
                 <a:cs typeface="Arial"/>
               </a:rPr>
-              <a:t>Dispatch / invoice</a:t>
+              <a:t>Factory false-positive rate</a:t>
             </a:r>
           </a:p>
         </p:txBody>
@@ -17087,7 +17077,7 @@
                 <a:ea typeface="Arial"/>
                 <a:cs typeface="Arial"/>
               </a:rPr>
-              <a:t>1.004 s</a:t>
+              <a:t>84.17%</a:t>
             </a:r>
           </a:p>
         </p:txBody>
@@ -17259,7 +17249,7 @@
                 <a:ea typeface="Arial"/>
                 <a:cs typeface="Arial"/>
               </a:rPr>
-              <a:t>Stock roll-forward</a:t>
+              <a:t>Monthly queue precision @ 50</a:t>
             </a:r>
           </a:p>
         </p:txBody>
@@ -17431,7 +17421,7 @@
                 <a:ea typeface="Arial"/>
                 <a:cs typeface="Arial"/>
               </a:rPr>
-              <a:t>0.011 s</a:t>
+              <a:t>18.17%</a:t>
             </a:r>
           </a:p>
         </p:txBody>
@@ -17603,7 +17593,7 @@
                 <a:ea typeface="Arial"/>
                 <a:cs typeface="Arial"/>
               </a:rPr>
-              <a:t>Supplier loop</a:t>
+              <a:t>Monthly queue precision @ 200</a:t>
             </a:r>
           </a:p>
         </p:txBody>
@@ -17775,7 +17765,7 @@
                 <a:ea typeface="Arial"/>
                 <a:cs typeface="Arial"/>
               </a:rPr>
-              <a:t>0.729 s</a:t>
+              <a:t>51.58%</a:t>
             </a:r>
           </a:p>
         </p:txBody>
@@ -17947,7 +17937,7 @@
                 <a:ea typeface="Arial"/>
                 <a:cs typeface="Arial"/>
               </a:rPr>
-              <a:t>Ranked cases</a:t>
+              <a:t>Single-signal decoy months</a:t>
             </a:r>
           </a:p>
         </p:txBody>
@@ -18119,7 +18109,7 @@
                 <a:ea typeface="Arial"/>
                 <a:cs typeface="Arial"/>
               </a:rPr>
-              <a:t>1.299 s</a:t>
+              <a:t>6924</a:t>
             </a:r>
           </a:p>
         </p:txBody>
@@ -18291,7 +18281,7 @@
                 <a:ea typeface="Arial"/>
                 <a:cs typeface="Arial"/>
               </a:rPr>
-              <a:t>Seeded synthetic data · local 8 GB VM · one measured run · not a real-world fraud benchmark</a:t>
+              <a:t>Synthetic data only. Threshold selected on A. High FPR prevents operational use. CIs and misses in README.</a:t>
             </a:r>
           </a:p>
         </p:txBody>
@@ -19211,7 +19201,7 @@
                 <a:ea typeface="Arial"/>
                 <a:cs typeface="Arial"/>
               </a:rPr>
-              <a:t>The reconciliation idea travels. The tax rules do not.</a:t>
+              <a:t>A possible adaptation requiring local evidence and validation</a:t>
             </a:r>
           </a:p>
         </p:txBody>
@@ -20609,7 +20599,7 @@
                 <a:ea typeface="Arial"/>
                 <a:cs typeface="Arial"/>
               </a:rPr>
-              <a:t>EPPO reported a suspected Germany-linked €18m carousel VAT case in May 2026, involving missing traders and cross-border invoice chains.</a:t>
+              <a:t>A Germany adaptation would reconcile invoice chains, goods movements and payments under locally validated rules.</a:t>
             </a:r>
           </a:p>
         </p:txBody>

</xml_diff>